<commit_message>
Refresh screenshots with current theme
</commit_message>
<xml_diff>
--- a/docs/Plastic_Hunter_Final_Presentation.pptx
+++ b/docs/Plastic_Hunter_Final_Presentation.pptx
@@ -1530,7 +1530,7 @@
         <p:spPr>
           <a:xfrm>
             <a:off x="502920" y="320040"/>
-            <a:ext cx="2926080" cy="228600"/>
+            <a:ext cx="2377440" cy="219456"/>
           </a:xfrm>
           <a:prstGeom prst="rect">
             <a:avLst/>
@@ -1539,7 +1539,7 @@
           <a:ln/>
         </p:spPr>
         <p:txBody>
-          <a:bodyPr wrap="square" rtlCol="0" anchor="ctr"/>
+          <a:bodyPr wrap="square" lIns="0" tIns="0" rIns="0" bIns="0" rtlCol="0" anchor="ctr"/>
           <a:lstStyle/>
           <a:p>
             <a:pPr indent="0" marL="0">
@@ -1550,11 +1550,8 @@
                 <a:solidFill>
                   <a:srgbClr val="586878"/>
                 </a:solidFill>
-                <a:latin typeface="Aptos" pitchFamily="34" charset="0"/>
-                <a:ea typeface="Aptos" pitchFamily="34" charset="-122"/>
-                <a:cs typeface="Aptos" pitchFamily="34" charset="-120"/>
               </a:rPr>
-              <a:t>IEEE AESS SUSTAINABILITY HACKATHON 2026</a:t>
+              <a:t>PLASTIC HUNTER</a:t>
             </a:r>
             <a:endParaRPr lang="en-US" sz="900" dirty="0"/>
           </a:p>
@@ -1569,7 +1566,7 @@
         <p:spPr>
           <a:xfrm>
             <a:off x="502920" y="603504"/>
-            <a:ext cx="6766560" cy="411480"/>
+            <a:ext cx="7406640" cy="457200"/>
           </a:xfrm>
           <a:prstGeom prst="rect">
             <a:avLst/>
@@ -1591,9 +1588,6 @@
                 <a:solidFill>
                   <a:srgbClr val="102033"/>
                 </a:solidFill>
-                <a:latin typeface="Aptos Display" pitchFamily="34" charset="0"/>
-                <a:ea typeface="Aptos Display" pitchFamily="34" charset="-122"/>
-                <a:cs typeface="Aptos Display" pitchFamily="34" charset="-120"/>
               </a:rPr>
               <a:t>Marine pollution monitoring with quieter sensing</a:t>
             </a:r>
@@ -1610,7 +1604,7 @@
         <p:spPr>
           <a:xfrm>
             <a:off x="502920" y="1133856"/>
-            <a:ext cx="11064240" cy="0"/>
+            <a:ext cx="11109960" cy="0"/>
           </a:xfrm>
           <a:prstGeom prst="line">
             <a:avLst/>
@@ -1626,7 +1620,7 @@
       </p:sp>
       <p:pic>
         <p:nvPicPr>
-          <p:cNvPr id="6" name="Image 0" descr="Plastic Hunter hero dashboard screenshot">    </p:cNvPr>
+          <p:cNvPr id="6" name="Image 0" descr="Marine pollution monitoring with quieter sensing">    </p:cNvPr>
           <p:cNvPicPr>
             <a:picLocks noChangeAspect="1"/>
           </p:cNvPicPr>
@@ -1656,8 +1650,8 @@
         </p:nvSpPr>
         <p:spPr>
           <a:xfrm>
-            <a:off x="7726680" y="1444752"/>
-            <a:ext cx="3611880" cy="1691640"/>
+            <a:off x="7726680" y="1508760"/>
+            <a:ext cx="3474720" cy="1828800"/>
           </a:xfrm>
           <a:prstGeom prst="rect">
             <a:avLst/>
@@ -1675,187 +1669,27 @@
               <a:buNone/>
             </a:pPr>
             <a:r>
-              <a:rPr lang="en-US" sz="1900" b="1" dirty="0">
+              <a:rPr lang="en-US" sz="1800" b="1" dirty="0">
                 <a:solidFill>
                   <a:srgbClr val="102033"/>
                 </a:solidFill>
               </a:rPr>
-              <a:t>Plastic Hunter combines a browser demo, FastAPI backend, SQLite mission logging, research-backed CV validation, and a reproducible eco-sonar simulation.</a:t>
-            </a:r>
-            <a:endParaRPr lang="en-US" sz="1900" dirty="0"/>
-          </a:p>
-        </p:txBody>
-      </p:sp>
-      <p:sp>
-        <p:nvSpPr>
-          <p:cNvPr id="8" name="Text 5"/>
-          <p:cNvSpPr/>
-          <p:nvPr/>
-        </p:nvSpPr>
-        <p:spPr>
-          <a:xfrm>
-            <a:off x="7726680" y="3401568"/>
-            <a:ext cx="1417320" cy="420624"/>
-          </a:xfrm>
-          <a:prstGeom prst="rect">
-            <a:avLst/>
-          </a:prstGeom>
-          <a:noFill/>
-          <a:ln/>
-        </p:spPr>
-        <p:txBody>
-          <a:bodyPr wrap="square" lIns="0" tIns="0" rIns="0" bIns="0" rtlCol="0" anchor="ctr"/>
-          <a:lstStyle/>
-          <a:p>
-            <a:pPr algn="ctr" indent="0" marL="0">
-              <a:buNone/>
-            </a:pPr>
-            <a:r>
-              <a:rPr lang="en-US" sz="2300" b="1" dirty="0">
-                <a:solidFill>
-                  <a:srgbClr val="2F7D57"/>
-                </a:solidFill>
-                <a:latin typeface="Aptos Display" pitchFamily="34" charset="0"/>
-                <a:ea typeface="Aptos Display" pitchFamily="34" charset="-122"/>
-                <a:cs typeface="Aptos Display" pitchFamily="34" charset="-120"/>
-              </a:rPr>
-              <a:t>~98%</a:t>
-            </a:r>
-            <a:endParaRPr lang="en-US" sz="2300" dirty="0"/>
-          </a:p>
-        </p:txBody>
-      </p:sp>
-      <p:sp>
-        <p:nvSpPr>
-          <p:cNvPr id="9" name="Text 6"/>
-          <p:cNvSpPr/>
-          <p:nvPr/>
-        </p:nvSpPr>
-        <p:spPr>
-          <a:xfrm>
-            <a:off x="7726680" y="3858768"/>
-            <a:ext cx="1417320" cy="347472"/>
-          </a:xfrm>
-          <a:prstGeom prst="rect">
-            <a:avLst/>
-          </a:prstGeom>
-          <a:noFill/>
-          <a:ln/>
-        </p:spPr>
-        <p:txBody>
-          <a:bodyPr wrap="square" lIns="254" tIns="254" rIns="254" bIns="254" rtlCol="0" anchor="ctr">
-            <a:normAutofit/>
-          </a:bodyPr>
-          <a:lstStyle/>
-          <a:p>
-            <a:pPr algn="ctr" indent="0" marL="0">
-              <a:buNone/>
-            </a:pPr>
-            <a:r>
-              <a:rPr lang="en-US" sz="950" dirty="0">
-                <a:solidFill>
-                  <a:srgbClr val="586878"/>
-                </a:solidFill>
-                <a:latin typeface="Aptos" pitchFamily="34" charset="0"/>
-                <a:ea typeface="Aptos" pitchFamily="34" charset="-122"/>
-                <a:cs typeface="Aptos" pitchFamily="34" charset="-120"/>
-              </a:rPr>
-              <a:t>acoustic SEL reduction in eco mode</a:t>
-            </a:r>
-            <a:endParaRPr lang="en-US" sz="950" dirty="0"/>
-          </a:p>
-        </p:txBody>
-      </p:sp>
-      <p:sp>
-        <p:nvSpPr>
-          <p:cNvPr id="10" name="Text 7"/>
-          <p:cNvSpPr/>
-          <p:nvPr/>
-        </p:nvSpPr>
-        <p:spPr>
-          <a:xfrm>
-            <a:off x="9464040" y="3401568"/>
-            <a:ext cx="1417320" cy="420624"/>
-          </a:xfrm>
-          <a:prstGeom prst="rect">
-            <a:avLst/>
-          </a:prstGeom>
-          <a:noFill/>
-          <a:ln/>
-        </p:spPr>
-        <p:txBody>
-          <a:bodyPr wrap="square" lIns="0" tIns="0" rIns="0" bIns="0" rtlCol="0" anchor="ctr"/>
-          <a:lstStyle/>
-          <a:p>
-            <a:pPr algn="ctr" indent="0" marL="0">
-              <a:buNone/>
-            </a:pPr>
-            <a:r>
-              <a:rPr lang="en-US" sz="2300" b="1" dirty="0">
-                <a:solidFill>
-                  <a:srgbClr val="2F7D57"/>
-                </a:solidFill>
-                <a:latin typeface="Aptos Display" pitchFamily="34" charset="0"/>
-                <a:ea typeface="Aptos Display" pitchFamily="34" charset="-122"/>
-                <a:cs typeface="Aptos Display" pitchFamily="34" charset="-120"/>
-              </a:rPr>
-              <a:t>&gt;90%</a:t>
-            </a:r>
-            <a:endParaRPr lang="en-US" sz="2300" dirty="0"/>
-          </a:p>
-        </p:txBody>
-      </p:sp>
-      <p:sp>
-        <p:nvSpPr>
-          <p:cNvPr id="11" name="Text 8"/>
-          <p:cNvSpPr/>
-          <p:nvPr/>
-        </p:nvSpPr>
-        <p:spPr>
-          <a:xfrm>
-            <a:off x="9464040" y="3858768"/>
-            <a:ext cx="1417320" cy="347472"/>
-          </a:xfrm>
-          <a:prstGeom prst="rect">
-            <a:avLst/>
-          </a:prstGeom>
-          <a:noFill/>
-          <a:ln/>
-        </p:spPr>
-        <p:txBody>
-          <a:bodyPr wrap="square" lIns="254" tIns="254" rIns="254" bIns="254" rtlCol="0" anchor="ctr">
-            <a:normAutofit/>
-          </a:bodyPr>
-          <a:lstStyle/>
-          <a:p>
-            <a:pPr algn="ctr" indent="0" marL="0">
-              <a:buNone/>
-            </a:pPr>
-            <a:r>
-              <a:rPr lang="en-US" sz="950" dirty="0">
-                <a:solidFill>
-                  <a:srgbClr val="586878"/>
-                </a:solidFill>
-                <a:latin typeface="Aptos" pitchFamily="34" charset="0"/>
-                <a:ea typeface="Aptos" pitchFamily="34" charset="-122"/>
-                <a:cs typeface="Aptos" pitchFamily="34" charset="-120"/>
-              </a:rPr>
-              <a:t>detection coverage retained</a:t>
-            </a:r>
-            <a:endParaRPr lang="en-US" sz="950" dirty="0"/>
-          </a:p>
-        </p:txBody>
-      </p:sp>
-      <p:sp>
-        <p:nvSpPr>
-          <p:cNvPr id="12" name="Shape 9"/>
-          <p:cNvSpPr/>
-          <p:nvPr/>
-        </p:nvSpPr>
-        <p:spPr>
-          <a:xfrm>
-            <a:off x="8001000" y="4709160"/>
-            <a:ext cx="2971800" cy="384048"/>
+              <a:t>Plastic Hunter combines browser UI, FastAPI, SQLite logging, CV validation, and eco-sonar simulation.</a:t>
+            </a:r>
+            <a:endParaRPr lang="en-US" sz="1800" dirty="0"/>
+          </a:p>
+        </p:txBody>
+      </p:sp>
+      <p:sp>
+        <p:nvSpPr>
+          <p:cNvPr id="8" name="Shape 5"/>
+          <p:cNvSpPr/>
+          <p:nvPr/>
+        </p:nvSpPr>
+        <p:spPr>
+          <a:xfrm>
+            <a:off x="7790688" y="4526280"/>
+            <a:ext cx="3246120" cy="384048"/>
           </a:xfrm>
           <a:prstGeom prst="roundRect">
             <a:avLst>
@@ -1877,14 +1711,14 @@
       </p:sp>
       <p:sp>
         <p:nvSpPr>
-          <p:cNvPr id="13" name="Text 10"/>
-          <p:cNvSpPr/>
-          <p:nvPr/>
-        </p:nvSpPr>
-        <p:spPr>
-          <a:xfrm>
-            <a:off x="8110728" y="4800600"/>
-            <a:ext cx="2752344" cy="164592"/>
+          <p:cNvPr id="9" name="Text 6"/>
+          <p:cNvSpPr/>
+          <p:nvPr/>
+        </p:nvSpPr>
+        <p:spPr>
+          <a:xfrm>
+            <a:off x="7882128" y="4617720"/>
+            <a:ext cx="3063240" cy="164592"/>
           </a:xfrm>
           <a:prstGeom prst="rect">
             <a:avLst/>
@@ -1893,7 +1727,9 @@
           <a:ln/>
         </p:spPr>
         <p:txBody>
-          <a:bodyPr wrap="square" lIns="0" tIns="0" rIns="0" bIns="0" rtlCol="0" anchor="ctr"/>
+          <a:bodyPr wrap="square" lIns="0" tIns="0" rIns="0" bIns="0" rtlCol="0" anchor="ctr">
+            <a:normAutofit/>
+          </a:bodyPr>
           <a:lstStyle/>
           <a:p>
             <a:pPr algn="ctr" indent="0" marL="0">
@@ -1975,7 +1811,7 @@
         <p:spPr>
           <a:xfrm>
             <a:off x="502920" y="320040"/>
-            <a:ext cx="2926080" cy="228600"/>
+            <a:ext cx="2377440" cy="219456"/>
           </a:xfrm>
           <a:prstGeom prst="rect">
             <a:avLst/>
@@ -1984,7 +1820,7 @@
           <a:ln/>
         </p:spPr>
         <p:txBody>
-          <a:bodyPr wrap="square" rtlCol="0" anchor="ctr"/>
+          <a:bodyPr wrap="square" lIns="0" tIns="0" rIns="0" bIns="0" rtlCol="0" anchor="ctr"/>
           <a:lstStyle/>
           <a:p>
             <a:pPr indent="0" marL="0">
@@ -1995,9 +1831,6 @@
                 <a:solidFill>
                   <a:srgbClr val="586878"/>
                 </a:solidFill>
-                <a:latin typeface="Aptos" pitchFamily="34" charset="0"/>
-                <a:ea typeface="Aptos" pitchFamily="34" charset="-122"/>
-                <a:cs typeface="Aptos" pitchFamily="34" charset="-120"/>
               </a:rPr>
               <a:t>PLASTIC HUNTER</a:t>
             </a:r>
@@ -2014,7 +1847,7 @@
         <p:spPr>
           <a:xfrm>
             <a:off x="502920" y="603504"/>
-            <a:ext cx="6766560" cy="411480"/>
+            <a:ext cx="7406640" cy="457200"/>
           </a:xfrm>
           <a:prstGeom prst="rect">
             <a:avLst/>
@@ -2036,9 +1869,6 @@
                 <a:solidFill>
                   <a:srgbClr val="102033"/>
                 </a:solidFill>
-                <a:latin typeface="Aptos Display" pitchFamily="34" charset="0"/>
-                <a:ea typeface="Aptos Display" pitchFamily="34" charset="-122"/>
-                <a:cs typeface="Aptos Display" pitchFamily="34" charset="-120"/>
               </a:rPr>
               <a:t>The workflow turns sensing into judge-ready evidence</a:t>
             </a:r>
@@ -2055,7 +1885,7 @@
         <p:spPr>
           <a:xfrm>
             <a:off x="502920" y="1133856"/>
-            <a:ext cx="11064240" cy="0"/>
+            <a:ext cx="11109960" cy="0"/>
           </a:xfrm>
           <a:prstGeom prst="line">
             <a:avLst/>
@@ -2071,7 +1901,7 @@
       </p:sp>
       <p:pic>
         <p:nvPicPr>
-          <p:cNvPr id="6" name="Image 0" descr="Mission flow screenshot">    </p:cNvPr>
+          <p:cNvPr id="6" name="Image 0" descr="The workflow turns sensing into judge-ready evidence">    </p:cNvPr>
           <p:cNvPicPr>
             <a:picLocks noChangeAspect="1"/>
           </p:cNvPicPr>
@@ -2086,7 +1916,7 @@
         <p:spPr>
           <a:xfrm>
             <a:off x="502920" y="1353312"/>
-            <a:ext cx="6492240" cy="4480560"/>
+            <a:ext cx="6903720" cy="4526280"/>
           </a:xfrm>
           <a:prstGeom prst="rect">
             <a:avLst/>
@@ -2101,8 +1931,8 @@
         </p:nvSpPr>
         <p:spPr>
           <a:xfrm>
-            <a:off x="7360920" y="1572768"/>
-            <a:ext cx="3794760" cy="2331720"/>
+            <a:off x="7726680" y="1508760"/>
+            <a:ext cx="3474720" cy="1828800"/>
           </a:xfrm>
           <a:prstGeom prst="rect">
             <a:avLst/>
@@ -2111,65 +1941,90 @@
           <a:ln/>
         </p:spPr>
         <p:txBody>
-          <a:bodyPr wrap="square" lIns="1016" tIns="1016" rIns="1016" bIns="1016" rtlCol="0" anchor="ctr">
+          <a:bodyPr wrap="square" lIns="0" tIns="0" rIns="0" bIns="0" rtlCol="0" anchor="ctr">
             <a:normAutofit/>
           </a:bodyPr>
           <a:lstStyle/>
           <a:p>
-            <a:r>
-              <a:rPr lang="en-US" sz="1450" dirty="0">
+            <a:pPr indent="0" marL="0">
+              <a:buNone/>
+            </a:pPr>
+            <a:r>
+              <a:rPr lang="en-US" sz="1800" b="1" dirty="0">
                 <a:solidFill>
                   <a:srgbClr val="102033"/>
                 </a:solidFill>
-                <a:latin typeface="Aptos" pitchFamily="34" charset="0"/>
-                <a:ea typeface="Aptos" pitchFamily="34" charset="-122"/>
-                <a:cs typeface="Aptos" pitchFamily="34" charset="-120"/>
               </a:rPr>
-              <a:t>Mission starts with passive or low-duty acoustic sensing.</a:t>
-            </a:r>
-            <a:endParaRPr lang="en-US" sz="1450" dirty="0"/>
-          </a:p>
-          <a:p>
-            <a:r>
-              <a:rPr lang="en-US" sz="1450" dirty="0">
+              <a:t>The dashboard shows the complete monitoring path from sensing assumptions to reviewable outputs.</a:t>
+            </a:r>
+            <a:endParaRPr lang="en-US" sz="1800" dirty="0"/>
+          </a:p>
+        </p:txBody>
+      </p:sp>
+      <p:sp>
+        <p:nvSpPr>
+          <p:cNvPr id="8" name="Shape 5"/>
+          <p:cNvSpPr/>
+          <p:nvPr/>
+        </p:nvSpPr>
+        <p:spPr>
+          <a:xfrm>
+            <a:off x="7790688" y="4526280"/>
+            <a:ext cx="3246120" cy="384048"/>
+          </a:xfrm>
+          <a:prstGeom prst="roundRect">
+            <a:avLst>
+              <a:gd name="adj" fmla="val 19048"/>
+            </a:avLst>
+          </a:prstGeom>
+          <a:solidFill>
+            <a:srgbClr val="24313F"/>
+          </a:solidFill>
+          <a:ln w="12700">
+            <a:solidFill>
+              <a:srgbClr val="24313F">
+                <a:alpha val="0"/>
+              </a:srgbClr>
+            </a:solidFill>
+            <a:prstDash val="solid"/>
+          </a:ln>
+        </p:spPr>
+      </p:sp>
+      <p:sp>
+        <p:nvSpPr>
+          <p:cNvPr id="9" name="Text 6"/>
+          <p:cNvSpPr/>
+          <p:nvPr/>
+        </p:nvSpPr>
+        <p:spPr>
+          <a:xfrm>
+            <a:off x="7882128" y="4617720"/>
+            <a:ext cx="3063240" cy="164592"/>
+          </a:xfrm>
+          <a:prstGeom prst="rect">
+            <a:avLst/>
+          </a:prstGeom>
+          <a:noFill/>
+          <a:ln/>
+        </p:spPr>
+        <p:txBody>
+          <a:bodyPr wrap="square" lIns="0" tIns="0" rIns="0" bIns="0" rtlCol="0" anchor="ctr">
+            <a:normAutofit/>
+          </a:bodyPr>
+          <a:lstStyle/>
+          <a:p>
+            <a:pPr algn="ctr" indent="0" marL="0">
+              <a:buNone/>
+            </a:pPr>
+            <a:r>
+              <a:rPr lang="en-US" sz="850" b="1" dirty="0">
                 <a:solidFill>
-                  <a:srgbClr val="102033"/>
+                  <a:srgbClr val="FFFFFF"/>
                 </a:solidFill>
-                <a:latin typeface="Aptos" pitchFamily="34" charset="0"/>
-                <a:ea typeface="Aptos" pitchFamily="34" charset="-122"/>
-                <a:cs typeface="Aptos" pitchFamily="34" charset="-120"/>
               </a:rPr>
-              <a:t>Hybrid decision logic routes likely detections to CV verification.</a:t>
-            </a:r>
-            <a:endParaRPr lang="en-US" sz="1450" dirty="0"/>
-          </a:p>
-          <a:p>
-            <a:r>
-              <a:rPr lang="en-US" sz="1450" dirty="0">
-                <a:solidFill>
-                  <a:srgbClr val="102033"/>
-                </a:solidFill>
-                <a:latin typeface="Aptos" pitchFamily="34" charset="0"/>
-                <a:ea typeface="Aptos" pitchFamily="34" charset="-122"/>
-                <a:cs typeface="Aptos" pitchFamily="34" charset="-120"/>
-              </a:rPr>
-              <a:t>SQLite stores mission records for the dashboard, map, and evidence sheet.</a:t>
-            </a:r>
-            <a:endParaRPr lang="en-US" sz="1450" dirty="0"/>
-          </a:p>
-          <a:p>
-            <a:r>
-              <a:rPr lang="en-US" sz="1450" dirty="0">
-                <a:solidFill>
-                  <a:srgbClr val="102033"/>
-                </a:solidFill>
-                <a:latin typeface="Aptos" pitchFamily="34" charset="0"/>
-                <a:ea typeface="Aptos" pitchFamily="34" charset="-122"/>
-                <a:cs typeface="Aptos" pitchFamily="34" charset="-120"/>
-              </a:rPr>
-              <a:t>Judges can inspect assumptions through dedicated evidence and disclosure views.</a:t>
-            </a:r>
-            <a:endParaRPr lang="en-US" sz="1450" dirty="0"/>
+              <a:t>Mission -&gt; sonar -&gt; CV -&gt; database -&gt; evidence</a:t>
+            </a:r>
+            <a:endParaRPr lang="en-US" sz="850" dirty="0"/>
           </a:p>
         </p:txBody>
       </p:sp>
@@ -2237,7 +2092,7 @@
         <p:spPr>
           <a:xfrm>
             <a:off x="502920" y="320040"/>
-            <a:ext cx="2926080" cy="228600"/>
+            <a:ext cx="2377440" cy="219456"/>
           </a:xfrm>
           <a:prstGeom prst="rect">
             <a:avLst/>
@@ -2246,7 +2101,7 @@
           <a:ln/>
         </p:spPr>
         <p:txBody>
-          <a:bodyPr wrap="square" rtlCol="0" anchor="ctr"/>
+          <a:bodyPr wrap="square" lIns="0" tIns="0" rIns="0" bIns="0" rtlCol="0" anchor="ctr"/>
           <a:lstStyle/>
           <a:p>
             <a:pPr indent="0" marL="0">
@@ -2257,9 +2112,6 @@
                 <a:solidFill>
                   <a:srgbClr val="586878"/>
                 </a:solidFill>
-                <a:latin typeface="Aptos" pitchFamily="34" charset="0"/>
-                <a:ea typeface="Aptos" pitchFamily="34" charset="-122"/>
-                <a:cs typeface="Aptos" pitchFamily="34" charset="-120"/>
               </a:rPr>
               <a:t>PLASTIC HUNTER</a:t>
             </a:r>
@@ -2276,7 +2128,7 @@
         <p:spPr>
           <a:xfrm>
             <a:off x="502920" y="603504"/>
-            <a:ext cx="6766560" cy="411480"/>
+            <a:ext cx="7406640" cy="457200"/>
           </a:xfrm>
           <a:prstGeom prst="rect">
             <a:avLst/>
@@ -2298,11 +2150,8 @@
                 <a:solidFill>
                   <a:srgbClr val="102033"/>
                 </a:solidFill>
-                <a:latin typeface="Aptos Display" pitchFamily="34" charset="0"/>
-                <a:ea typeface="Aptos Display" pitchFamily="34" charset="-122"/>
-                <a:cs typeface="Aptos Display" pitchFamily="34" charset="-120"/>
               </a:rPr>
-              <a:t>The detection view preserves the live inspection workflow</a:t>
+              <a:t>The detection view preserves the inspection workflow</a:t>
             </a:r>
             <a:endParaRPr lang="en-US" sz="2500" dirty="0"/>
           </a:p>
@@ -2317,7 +2166,7 @@
         <p:spPr>
           <a:xfrm>
             <a:off x="502920" y="1133856"/>
-            <a:ext cx="11064240" cy="0"/>
+            <a:ext cx="11109960" cy="0"/>
           </a:xfrm>
           <a:prstGeom prst="line">
             <a:avLst/>
@@ -2333,7 +2182,7 @@
       </p:sp>
       <p:pic>
         <p:nvPicPr>
-          <p:cNvPr id="6" name="Image 0" descr="Detection interface screenshot">    </p:cNvPr>
+          <p:cNvPr id="6" name="Image 0" descr="The detection view preserves the inspection workflow">    </p:cNvPr>
           <p:cNvPicPr>
             <a:picLocks noChangeAspect="1"/>
           </p:cNvPicPr>
@@ -2348,7 +2197,7 @@
         <p:spPr>
           <a:xfrm>
             <a:off x="502920" y="1353312"/>
-            <a:ext cx="6629400" cy="4526280"/>
+            <a:ext cx="6903720" cy="4526280"/>
           </a:xfrm>
           <a:prstGeom prst="rect">
             <a:avLst/>
@@ -2363,8 +2212,8 @@
         </p:nvSpPr>
         <p:spPr>
           <a:xfrm>
-            <a:off x="7452360" y="1591056"/>
-            <a:ext cx="3611880" cy="2331720"/>
+            <a:off x="7726680" y="1508760"/>
+            <a:ext cx="3474720" cy="1828800"/>
           </a:xfrm>
           <a:prstGeom prst="rect">
             <a:avLst/>
@@ -2373,51 +2222,23 @@
           <a:ln/>
         </p:spPr>
         <p:txBody>
-          <a:bodyPr wrap="square" lIns="1016" tIns="1016" rIns="1016" bIns="1016" rtlCol="0" anchor="ctr">
+          <a:bodyPr wrap="square" lIns="0" tIns="0" rIns="0" bIns="0" rtlCol="0" anchor="ctr">
             <a:normAutofit/>
           </a:bodyPr>
           <a:lstStyle/>
           <a:p>
-            <a:r>
-              <a:rPr lang="en-US" sz="1450" dirty="0">
+            <a:pPr indent="0" marL="0">
+              <a:buNone/>
+            </a:pPr>
+            <a:r>
+              <a:rPr lang="en-US" sz="1800" b="1" dirty="0">
                 <a:solidFill>
                   <a:srgbClr val="102033"/>
                 </a:solidFill>
-                <a:latin typeface="Aptos" pitchFamily="34" charset="0"/>
-                <a:ea typeface="Aptos" pitchFamily="34" charset="-122"/>
-                <a:cs typeface="Aptos" pitchFamily="34" charset="-120"/>
               </a:rPr>
-              <a:t>Uploads are validated for type and size before analysis.</a:t>
-            </a:r>
-            <a:endParaRPr lang="en-US" sz="1450" dirty="0"/>
-          </a:p>
-          <a:p>
-            <a:r>
-              <a:rPr lang="en-US" sz="1450" dirty="0">
-                <a:solidFill>
-                  <a:srgbClr val="102033"/>
-                </a:solidFill>
-                <a:latin typeface="Aptos" pitchFamily="34" charset="0"/>
-                <a:ea typeface="Aptos" pitchFamily="34" charset="-122"/>
-                <a:cs typeface="Aptos" pitchFamily="34" charset="-120"/>
-              </a:rPr>
-              <a:t>The demo uses a portable Pillow and NumPy interface for constrained hosting.</a:t>
-            </a:r>
-            <a:endParaRPr lang="en-US" sz="1450" dirty="0"/>
-          </a:p>
-          <a:p>
-            <a:r>
-              <a:rPr lang="en-US" sz="1450" dirty="0">
-                <a:solidFill>
-                  <a:srgbClr val="102033"/>
-                </a:solidFill>
-                <a:latin typeface="Aptos" pitchFamily="34" charset="0"/>
-                <a:ea typeface="Aptos" pitchFamily="34" charset="-122"/>
-                <a:cs typeface="Aptos" pitchFamily="34" charset="-120"/>
-              </a:rPr>
-              <a:t>Trained CV results are reported separately as the research validation track.</a:t>
-            </a:r>
-            <a:endParaRPr lang="en-US" sz="1450" dirty="0"/>
+              <a:t>The portable demo keeps the upload, detection, annotation, and logging flow visible for judges.</a:t>
+            </a:r>
+            <a:endParaRPr lang="en-US" sz="1800" dirty="0"/>
           </a:p>
         </p:txBody>
       </p:sp>
@@ -2429,8 +2250,8 @@
         </p:nvSpPr>
         <p:spPr>
           <a:xfrm>
-            <a:off x="7479792" y="4462272"/>
-            <a:ext cx="3520440" cy="384048"/>
+            <a:off x="7790688" y="4526280"/>
+            <a:ext cx="3246120" cy="384048"/>
           </a:xfrm>
           <a:prstGeom prst="roundRect">
             <a:avLst>
@@ -2438,11 +2259,11 @@
             </a:avLst>
           </a:prstGeom>
           <a:solidFill>
-            <a:srgbClr val="2F7D57"/>
+            <a:srgbClr val="24313F"/>
           </a:solidFill>
           <a:ln w="12700">
             <a:solidFill>
-              <a:srgbClr val="2F7D57">
+              <a:srgbClr val="24313F">
                 <a:alpha val="0"/>
               </a:srgbClr>
             </a:solidFill>
@@ -2458,8 +2279,8 @@
         </p:nvSpPr>
         <p:spPr>
           <a:xfrm>
-            <a:off x="7589520" y="4553712"/>
-            <a:ext cx="3300984" cy="164592"/>
+            <a:off x="7882128" y="4617720"/>
+            <a:ext cx="3063240" cy="164592"/>
           </a:xfrm>
           <a:prstGeom prst="rect">
             <a:avLst/>
@@ -2468,7 +2289,9 @@
           <a:ln/>
         </p:spPr>
         <p:txBody>
-          <a:bodyPr wrap="square" lIns="0" tIns="0" rIns="0" bIns="0" rtlCol="0" anchor="ctr"/>
+          <a:bodyPr wrap="square" lIns="0" tIns="0" rIns="0" bIns="0" rtlCol="0" anchor="ctr">
+            <a:normAutofit/>
+          </a:bodyPr>
           <a:lstStyle/>
           <a:p>
             <a:pPr algn="ctr" indent="0" marL="0">
@@ -2550,7 +2373,7 @@
         <p:spPr>
           <a:xfrm>
             <a:off x="502920" y="320040"/>
-            <a:ext cx="2926080" cy="228600"/>
+            <a:ext cx="2377440" cy="219456"/>
           </a:xfrm>
           <a:prstGeom prst="rect">
             <a:avLst/>
@@ -2559,7 +2382,7 @@
           <a:ln/>
         </p:spPr>
         <p:txBody>
-          <a:bodyPr wrap="square" rtlCol="0" anchor="ctr"/>
+          <a:bodyPr wrap="square" lIns="0" tIns="0" rIns="0" bIns="0" rtlCol="0" anchor="ctr"/>
           <a:lstStyle/>
           <a:p>
             <a:pPr indent="0" marL="0">
@@ -2570,9 +2393,6 @@
                 <a:solidFill>
                   <a:srgbClr val="586878"/>
                 </a:solidFill>
-                <a:latin typeface="Aptos" pitchFamily="34" charset="0"/>
-                <a:ea typeface="Aptos" pitchFamily="34" charset="-122"/>
-                <a:cs typeface="Aptos" pitchFamily="34" charset="-120"/>
               </a:rPr>
               <a:t>PLASTIC HUNTER</a:t>
             </a:r>
@@ -2589,7 +2409,7 @@
         <p:spPr>
           <a:xfrm>
             <a:off x="502920" y="603504"/>
-            <a:ext cx="6766560" cy="411480"/>
+            <a:ext cx="7406640" cy="457200"/>
           </a:xfrm>
           <a:prstGeom prst="rect">
             <a:avLst/>
@@ -2611,9 +2431,6 @@
                 <a:solidFill>
                   <a:srgbClr val="102033"/>
                 </a:solidFill>
-                <a:latin typeface="Aptos Display" pitchFamily="34" charset="0"/>
-                <a:ea typeface="Aptos Display" pitchFamily="34" charset="-122"/>
-                <a:cs typeface="Aptos Display" pitchFamily="34" charset="-120"/>
               </a:rPr>
               <a:t>Eco-sonar quantifies the sustainability trade-off</a:t>
             </a:r>
@@ -2630,7 +2447,7 @@
         <p:spPr>
           <a:xfrm>
             <a:off x="502920" y="1133856"/>
-            <a:ext cx="11064240" cy="0"/>
+            <a:ext cx="11109960" cy="0"/>
           </a:xfrm>
           <a:prstGeom prst="line">
             <a:avLst/>
@@ -2646,7 +2463,7 @@
       </p:sp>
       <p:pic>
         <p:nvPicPr>
-          <p:cNvPr id="6" name="Image 0" descr="Eco sonar simulation screenshot">    </p:cNvPr>
+          <p:cNvPr id="6" name="Image 0" descr="Eco-sonar quantifies the sustainability trade-off">    </p:cNvPr>
           <p:cNvPicPr>
             <a:picLocks noChangeAspect="1"/>
           </p:cNvPicPr>
@@ -2661,7 +2478,7 @@
         <p:spPr>
           <a:xfrm>
             <a:off x="502920" y="1353312"/>
-            <a:ext cx="6629400" cy="4526280"/>
+            <a:ext cx="6903720" cy="4526280"/>
           </a:xfrm>
           <a:prstGeom prst="rect">
             <a:avLst/>
@@ -2676,8 +2493,8 @@
         </p:nvSpPr>
         <p:spPr>
           <a:xfrm>
-            <a:off x="7406640" y="1508760"/>
-            <a:ext cx="3657600" cy="2331720"/>
+            <a:off x="7726680" y="1508760"/>
+            <a:ext cx="3474720" cy="1828800"/>
           </a:xfrm>
           <a:prstGeom prst="rect">
             <a:avLst/>
@@ -2686,64 +2503,65 @@
           <a:ln/>
         </p:spPr>
         <p:txBody>
-          <a:bodyPr wrap="square" lIns="1016" tIns="1016" rIns="1016" bIns="1016" rtlCol="0" anchor="ctr">
+          <a:bodyPr wrap="square" lIns="0" tIns="0" rIns="0" bIns="0" rtlCol="0" anchor="ctr">
             <a:normAutofit/>
           </a:bodyPr>
           <a:lstStyle/>
           <a:p>
-            <a:r>
-              <a:rPr lang="en-US" sz="1450" dirty="0">
+            <a:pPr indent="0" marL="0">
+              <a:buNone/>
+            </a:pPr>
+            <a:r>
+              <a:rPr lang="en-US" sz="1800" b="1" dirty="0">
                 <a:solidFill>
                   <a:srgbClr val="102033"/>
                 </a:solidFill>
-                <a:latin typeface="Aptos" pitchFamily="34" charset="0"/>
-                <a:ea typeface="Aptos" pitchFamily="34" charset="-122"/>
-                <a:cs typeface="Aptos" pitchFamily="34" charset="-120"/>
               </a:rPr>
-              <a:t>Mackenzie sound speed, Thorp absorption, and Knudsen-Wenz ambient noise.</a:t>
-            </a:r>
-            <a:endParaRPr lang="en-US" sz="1450" dirty="0"/>
-          </a:p>
-          <a:p>
-            <a:r>
-              <a:rPr lang="en-US" sz="1450" dirty="0">
-                <a:solidFill>
-                  <a:srgbClr val="102033"/>
-                </a:solidFill>
-                <a:latin typeface="Aptos" pitchFamily="34" charset="0"/>
-                <a:ea typeface="Aptos" pitchFamily="34" charset="-122"/>
-                <a:cs typeface="Aptos" pitchFamily="34" charset="-120"/>
-              </a:rPr>
-              <a:t>Compares conventional active sonar with eco-adaptive and passive modes.</a:t>
-            </a:r>
-            <a:endParaRPr lang="en-US" sz="1450" dirty="0"/>
-          </a:p>
-          <a:p>
-            <a:r>
-              <a:rPr lang="en-US" sz="1450" dirty="0">
-                <a:solidFill>
-                  <a:srgbClr val="102033"/>
-                </a:solidFill>
-                <a:latin typeface="Aptos" pitchFamily="34" charset="0"/>
-                <a:ea typeface="Aptos" pitchFamily="34" charset="-122"/>
-                <a:cs typeface="Aptos" pitchFamily="34" charset="-120"/>
-              </a:rPr>
-              <a:t>Reports range, detection probability, duty cycle, SEL, and energy proxy.</a:t>
-            </a:r>
-            <a:endParaRPr lang="en-US" sz="1450" dirty="0"/>
-          </a:p>
-        </p:txBody>
-      </p:sp>
-      <p:sp>
-        <p:nvSpPr>
-          <p:cNvPr id="8" name="Text 5"/>
-          <p:cNvSpPr/>
-          <p:nvPr/>
-        </p:nvSpPr>
-        <p:spPr>
-          <a:xfrm>
-            <a:off x="7498080" y="4443984"/>
-            <a:ext cx="1508760" cy="420624"/>
+              <a:t>The sonar simulation compares conventional, passive, and eco-adaptive modes with reproducible parameters.</a:t>
+            </a:r>
+            <a:endParaRPr lang="en-US" sz="1800" dirty="0"/>
+          </a:p>
+        </p:txBody>
+      </p:sp>
+      <p:sp>
+        <p:nvSpPr>
+          <p:cNvPr id="8" name="Shape 5"/>
+          <p:cNvSpPr/>
+          <p:nvPr/>
+        </p:nvSpPr>
+        <p:spPr>
+          <a:xfrm>
+            <a:off x="7790688" y="4526280"/>
+            <a:ext cx="3246120" cy="384048"/>
+          </a:xfrm>
+          <a:prstGeom prst="roundRect">
+            <a:avLst>
+              <a:gd name="adj" fmla="val 19048"/>
+            </a:avLst>
+          </a:prstGeom>
+          <a:solidFill>
+            <a:srgbClr val="2F7D57"/>
+          </a:solidFill>
+          <a:ln w="12700">
+            <a:solidFill>
+              <a:srgbClr val="2F7D57">
+                <a:alpha val="0"/>
+              </a:srgbClr>
+            </a:solidFill>
+            <a:prstDash val="solid"/>
+          </a:ln>
+        </p:spPr>
+      </p:sp>
+      <p:sp>
+        <p:nvSpPr>
+          <p:cNvPr id="9" name="Text 6"/>
+          <p:cNvSpPr/>
+          <p:nvPr/>
+        </p:nvSpPr>
+        <p:spPr>
+          <a:xfrm>
+            <a:off x="7882128" y="4617720"/>
+            <a:ext cx="3063240" cy="164592"/>
           </a:xfrm>
           <a:prstGeom prst="rect">
             <a:avLst/>
@@ -2752,145 +2570,23 @@
           <a:ln/>
         </p:spPr>
         <p:txBody>
-          <a:bodyPr wrap="square" lIns="0" tIns="0" rIns="0" bIns="0" rtlCol="0" anchor="ctr"/>
+          <a:bodyPr wrap="square" lIns="0" tIns="0" rIns="0" bIns="0" rtlCol="0" anchor="ctr">
+            <a:normAutofit/>
+          </a:bodyPr>
           <a:lstStyle/>
           <a:p>
             <a:pPr algn="ctr" indent="0" marL="0">
               <a:buNone/>
             </a:pPr>
             <a:r>
-              <a:rPr lang="en-US" sz="2300" b="1" dirty="0">
+              <a:rPr lang="en-US" sz="850" b="1" dirty="0">
                 <a:solidFill>
-                  <a:srgbClr val="0F766E"/>
+                  <a:srgbClr val="FFFFFF"/>
                 </a:solidFill>
-                <a:latin typeface="Aptos Display" pitchFamily="34" charset="0"/>
-                <a:ea typeface="Aptos Display" pitchFamily="34" charset="-122"/>
-                <a:cs typeface="Aptos Display" pitchFamily="34" charset="-120"/>
               </a:rPr>
-              <a:t>0.67%</a:t>
-            </a:r>
-            <a:endParaRPr lang="en-US" sz="2300" dirty="0"/>
-          </a:p>
-        </p:txBody>
-      </p:sp>
-      <p:sp>
-        <p:nvSpPr>
-          <p:cNvPr id="9" name="Text 6"/>
-          <p:cNvSpPr/>
-          <p:nvPr/>
-        </p:nvSpPr>
-        <p:spPr>
-          <a:xfrm>
-            <a:off x="7498080" y="4901184"/>
-            <a:ext cx="1508760" cy="347472"/>
-          </a:xfrm>
-          <a:prstGeom prst="rect">
-            <a:avLst/>
-          </a:prstGeom>
-          <a:noFill/>
-          <a:ln/>
-        </p:spPr>
-        <p:txBody>
-          <a:bodyPr wrap="square" lIns="254" tIns="254" rIns="254" bIns="254" rtlCol="0" anchor="ctr">
-            <a:normAutofit/>
-          </a:bodyPr>
-          <a:lstStyle/>
-          <a:p>
-            <a:pPr algn="ctr" indent="0" marL="0">
-              <a:buNone/>
-            </a:pPr>
-            <a:r>
-              <a:rPr lang="en-US" sz="950" dirty="0">
-                <a:solidFill>
-                  <a:srgbClr val="586878"/>
-                </a:solidFill>
-                <a:latin typeface="Aptos" pitchFamily="34" charset="0"/>
-                <a:ea typeface="Aptos" pitchFamily="34" charset="-122"/>
-                <a:cs typeface="Aptos" pitchFamily="34" charset="-120"/>
-              </a:rPr>
-              <a:t>eco-adaptive duty cycle</a:t>
-            </a:r>
-            <a:endParaRPr lang="en-US" sz="950" dirty="0"/>
-          </a:p>
-        </p:txBody>
-      </p:sp>
-      <p:sp>
-        <p:nvSpPr>
-          <p:cNvPr id="10" name="Text 7"/>
-          <p:cNvSpPr/>
-          <p:nvPr/>
-        </p:nvSpPr>
-        <p:spPr>
-          <a:xfrm>
-            <a:off x="9281160" y="4443984"/>
-            <a:ext cx="1508760" cy="420624"/>
-          </a:xfrm>
-          <a:prstGeom prst="rect">
-            <a:avLst/>
-          </a:prstGeom>
-          <a:noFill/>
-          <a:ln/>
-        </p:spPr>
-        <p:txBody>
-          <a:bodyPr wrap="square" lIns="0" tIns="0" rIns="0" bIns="0" rtlCol="0" anchor="ctr"/>
-          <a:lstStyle/>
-          <a:p>
-            <a:pPr algn="ctr" indent="0" marL="0">
-              <a:buNone/>
-            </a:pPr>
-            <a:r>
-              <a:rPr lang="en-US" sz="2300" b="1" dirty="0">
-                <a:solidFill>
-                  <a:srgbClr val="0F766E"/>
-                </a:solidFill>
-                <a:latin typeface="Aptos Display" pitchFamily="34" charset="0"/>
-                <a:ea typeface="Aptos Display" pitchFamily="34" charset="-122"/>
-                <a:cs typeface="Aptos Display" pitchFamily="34" charset="-120"/>
-              </a:rPr>
-              <a:t>-12 dB</a:t>
-            </a:r>
-            <a:endParaRPr lang="en-US" sz="2300" dirty="0"/>
-          </a:p>
-        </p:txBody>
-      </p:sp>
-      <p:sp>
-        <p:nvSpPr>
-          <p:cNvPr id="11" name="Text 8"/>
-          <p:cNvSpPr/>
-          <p:nvPr/>
-        </p:nvSpPr>
-        <p:spPr>
-          <a:xfrm>
-            <a:off x="9281160" y="4901184"/>
-            <a:ext cx="1508760" cy="347472"/>
-          </a:xfrm>
-          <a:prstGeom prst="rect">
-            <a:avLst/>
-          </a:prstGeom>
-          <a:noFill/>
-          <a:ln/>
-        </p:spPr>
-        <p:txBody>
-          <a:bodyPr wrap="square" lIns="254" tIns="254" rIns="254" bIns="254" rtlCol="0" anchor="ctr">
-            <a:normAutofit/>
-          </a:bodyPr>
-          <a:lstStyle/>
-          <a:p>
-            <a:pPr algn="ctr" indent="0" marL="0">
-              <a:buNone/>
-            </a:pPr>
-            <a:r>
-              <a:rPr lang="en-US" sz="950" dirty="0">
-                <a:solidFill>
-                  <a:srgbClr val="586878"/>
-                </a:solidFill>
-                <a:latin typeface="Aptos" pitchFamily="34" charset="0"/>
-                <a:ea typeface="Aptos" pitchFamily="34" charset="-122"/>
-                <a:cs typeface="Aptos" pitchFamily="34" charset="-120"/>
-              </a:rPr>
-              <a:t>source level adjustment</a:t>
-            </a:r>
-            <a:endParaRPr lang="en-US" sz="950" dirty="0"/>
+              <a:t>~98% SEL reduction, &gt;90% coverage retained</a:t>
+            </a:r>
+            <a:endParaRPr lang="en-US" sz="850" dirty="0"/>
           </a:p>
         </p:txBody>
       </p:sp>
@@ -2958,7 +2654,7 @@
         <p:spPr>
           <a:xfrm>
             <a:off x="502920" y="320040"/>
-            <a:ext cx="2926080" cy="228600"/>
+            <a:ext cx="2377440" cy="219456"/>
           </a:xfrm>
           <a:prstGeom prst="rect">
             <a:avLst/>
@@ -2967,7 +2663,7 @@
           <a:ln/>
         </p:spPr>
         <p:txBody>
-          <a:bodyPr wrap="square" rtlCol="0" anchor="ctr"/>
+          <a:bodyPr wrap="square" lIns="0" tIns="0" rIns="0" bIns="0" rtlCol="0" anchor="ctr"/>
           <a:lstStyle/>
           <a:p>
             <a:pPr indent="0" marL="0">
@@ -2978,9 +2674,6 @@
                 <a:solidFill>
                   <a:srgbClr val="586878"/>
                 </a:solidFill>
-                <a:latin typeface="Aptos" pitchFamily="34" charset="0"/>
-                <a:ea typeface="Aptos" pitchFamily="34" charset="-122"/>
-                <a:cs typeface="Aptos" pitchFamily="34" charset="-120"/>
               </a:rPr>
               <a:t>PLASTIC HUNTER</a:t>
             </a:r>
@@ -2997,7 +2690,7 @@
         <p:spPr>
           <a:xfrm>
             <a:off x="502920" y="603504"/>
-            <a:ext cx="6766560" cy="411480"/>
+            <a:ext cx="7406640" cy="457200"/>
           </a:xfrm>
           <a:prstGeom prst="rect">
             <a:avLst/>
@@ -3019,9 +2712,6 @@
                 <a:solidFill>
                   <a:srgbClr val="102033"/>
                 </a:solidFill>
-                <a:latin typeface="Aptos Display" pitchFamily="34" charset="0"/>
-                <a:ea typeface="Aptos Display" pitchFamily="34" charset="-122"/>
-                <a:cs typeface="Aptos Display" pitchFamily="34" charset="-120"/>
               </a:rPr>
               <a:t>The dashboard separates measured data from estimates</a:t>
             </a:r>
@@ -3038,7 +2728,7 @@
         <p:spPr>
           <a:xfrm>
             <a:off x="502920" y="1133856"/>
-            <a:ext cx="11064240" cy="0"/>
+            <a:ext cx="11109960" cy="0"/>
           </a:xfrm>
           <a:prstGeom prst="line">
             <a:avLst/>
@@ -3054,7 +2744,7 @@
       </p:sp>
       <p:pic>
         <p:nvPicPr>
-          <p:cNvPr id="6" name="Image 0" descr="Dashboard screenshot">    </p:cNvPr>
+          <p:cNvPr id="6" name="Image 0" descr="The dashboard separates measured data from estimates">    </p:cNvPr>
           <p:cNvPicPr>
             <a:picLocks noChangeAspect="1"/>
           </p:cNvPicPr>
@@ -3069,7 +2759,7 @@
         <p:spPr>
           <a:xfrm>
             <a:off x="502920" y="1353312"/>
-            <a:ext cx="6629400" cy="4526280"/>
+            <a:ext cx="6903720" cy="4526280"/>
           </a:xfrm>
           <a:prstGeom prst="rect">
             <a:avLst/>
@@ -3084,8 +2774,8 @@
         </p:nvSpPr>
         <p:spPr>
           <a:xfrm>
-            <a:off x="7406640" y="1591056"/>
-            <a:ext cx="3657600" cy="2331720"/>
+            <a:off x="7726680" y="1508760"/>
+            <a:ext cx="3474720" cy="1828800"/>
           </a:xfrm>
           <a:prstGeom prst="rect">
             <a:avLst/>
@@ -3094,51 +2784,23 @@
           <a:ln/>
         </p:spPr>
         <p:txBody>
-          <a:bodyPr wrap="square" lIns="1016" tIns="1016" rIns="1016" bIns="1016" rtlCol="0" anchor="ctr">
+          <a:bodyPr wrap="square" lIns="0" tIns="0" rIns="0" bIns="0" rtlCol="0" anchor="ctr">
             <a:normAutofit/>
           </a:bodyPr>
           <a:lstStyle/>
           <a:p>
-            <a:r>
-              <a:rPr lang="en-US" sz="1450" dirty="0">
+            <a:pPr indent="0" marL="0">
+              <a:buNone/>
+            </a:pPr>
+            <a:r>
+              <a:rPr lang="en-US" sz="1800" b="1" dirty="0">
                 <a:solidFill>
                   <a:srgbClr val="102033"/>
                 </a:solidFill>
-                <a:latin typeface="Aptos" pitchFamily="34" charset="0"/>
-                <a:ea typeface="Aptos" pitchFamily="34" charset="-122"/>
-                <a:cs typeface="Aptos" pitchFamily="34" charset="-120"/>
               </a:rPr>
-              <a:t>Observed detections come from SQLite mission records.</a:t>
-            </a:r>
-            <a:endParaRPr lang="en-US" sz="1450" dirty="0"/>
-          </a:p>
-          <a:p>
-            <a:r>
-              <a:rPr lang="en-US" sz="1450" dirty="0">
-                <a:solidFill>
-                  <a:srgbClr val="102033"/>
-                </a:solidFill>
-                <a:latin typeface="Aptos" pitchFamily="34" charset="0"/>
-                <a:ea typeface="Aptos" pitchFamily="34" charset="-122"/>
-                <a:cs typeface="Aptos" pitchFamily="34" charset="-120"/>
-              </a:rPr>
-              <a:t>Manual baseline comparison is labeled as a demo planning estimate.</a:t>
-            </a:r>
-            <a:endParaRPr lang="en-US" sz="1450" dirty="0"/>
-          </a:p>
-          <a:p>
-            <a:r>
-              <a:rPr lang="en-US" sz="1450" dirty="0">
-                <a:solidFill>
-                  <a:srgbClr val="102033"/>
-                </a:solidFill>
-                <a:latin typeface="Aptos" pitchFamily="34" charset="0"/>
-                <a:ea typeface="Aptos" pitchFamily="34" charset="-122"/>
-                <a:cs typeface="Aptos" pitchFamily="34" charset="-120"/>
-              </a:rPr>
-              <a:t>Plastic type mix is estimated for seeded rows that store total counts.</a:t>
-            </a:r>
-            <a:endParaRPr lang="en-US" sz="1450" dirty="0"/>
+              <a:t>Mission KPIs, confidence bands, and evidence status are presented with clear scope boundaries.</a:t>
+            </a:r>
+            <a:endParaRPr lang="en-US" sz="1800" dirty="0"/>
           </a:p>
         </p:txBody>
       </p:sp>
@@ -3150,8 +2812,8 @@
         </p:nvSpPr>
         <p:spPr>
           <a:xfrm>
-            <a:off x="7635240" y="4572000"/>
-            <a:ext cx="3063240" cy="384048"/>
+            <a:off x="7790688" y="4526280"/>
+            <a:ext cx="3246120" cy="384048"/>
           </a:xfrm>
           <a:prstGeom prst="roundRect">
             <a:avLst>
@@ -3179,8 +2841,8 @@
         </p:nvSpPr>
         <p:spPr>
           <a:xfrm>
-            <a:off x="7744968" y="4663440"/>
-            <a:ext cx="2843784" cy="164592"/>
+            <a:off x="7882128" y="4617720"/>
+            <a:ext cx="3063240" cy="164592"/>
           </a:xfrm>
           <a:prstGeom prst="rect">
             <a:avLst/>
@@ -3189,7 +2851,9 @@
           <a:ln/>
         </p:spPr>
         <p:txBody>
-          <a:bodyPr wrap="square" lIns="0" tIns="0" rIns="0" bIns="0" rtlCol="0" anchor="ctr"/>
+          <a:bodyPr wrap="square" lIns="0" tIns="0" rIns="0" bIns="0" rtlCol="0" anchor="ctr">
+            <a:normAutofit/>
+          </a:bodyPr>
           <a:lstStyle/>
           <a:p>
             <a:pPr algn="ctr" indent="0" marL="0">
@@ -3201,7 +2865,7 @@
                   <a:srgbClr val="FFFFFF"/>
                 </a:solidFill>
               </a:rPr>
-              <a:t>No hidden environmental impact claims</a:t>
+              <a:t>Observed records stay separate from planning estimates</a:t>
             </a:r>
             <a:endParaRPr lang="en-US" sz="850" dirty="0"/>
           </a:p>
@@ -3271,7 +2935,7 @@
         <p:spPr>
           <a:xfrm>
             <a:off x="502920" y="320040"/>
-            <a:ext cx="2926080" cy="228600"/>
+            <a:ext cx="2377440" cy="219456"/>
           </a:xfrm>
           <a:prstGeom prst="rect">
             <a:avLst/>
@@ -3280,7 +2944,7 @@
           <a:ln/>
         </p:spPr>
         <p:txBody>
-          <a:bodyPr wrap="square" rtlCol="0" anchor="ctr"/>
+          <a:bodyPr wrap="square" lIns="0" tIns="0" rIns="0" bIns="0" rtlCol="0" anchor="ctr"/>
           <a:lstStyle/>
           <a:p>
             <a:pPr indent="0" marL="0">
@@ -3291,9 +2955,6 @@
                 <a:solidFill>
                   <a:srgbClr val="586878"/>
                 </a:solidFill>
-                <a:latin typeface="Aptos" pitchFamily="34" charset="0"/>
-                <a:ea typeface="Aptos" pitchFamily="34" charset="-122"/>
-                <a:cs typeface="Aptos" pitchFamily="34" charset="-120"/>
               </a:rPr>
               <a:t>PLASTIC HUNTER</a:t>
             </a:r>
@@ -3310,7 +2971,7 @@
         <p:spPr>
           <a:xfrm>
             <a:off x="502920" y="603504"/>
-            <a:ext cx="6766560" cy="411480"/>
+            <a:ext cx="7406640" cy="457200"/>
           </a:xfrm>
           <a:prstGeom prst="rect">
             <a:avLst/>
@@ -3332,9 +2993,6 @@
                 <a:solidFill>
                   <a:srgbClr val="102033"/>
                 </a:solidFill>
-                <a:latin typeface="Aptos Display" pitchFamily="34" charset="0"/>
-                <a:ea typeface="Aptos Display" pitchFamily="34" charset="-122"/>
-                <a:cs typeface="Aptos Display" pitchFamily="34" charset="-120"/>
               </a:rPr>
               <a:t>The map makes inspection records spatially interpretable</a:t>
             </a:r>
@@ -3351,7 +3009,7 @@
         <p:spPr>
           <a:xfrm>
             <a:off x="502920" y="1133856"/>
-            <a:ext cx="11064240" cy="0"/>
+            <a:ext cx="11109960" cy="0"/>
           </a:xfrm>
           <a:prstGeom prst="line">
             <a:avLst/>
@@ -3367,7 +3025,7 @@
       </p:sp>
       <p:pic>
         <p:nvPicPr>
-          <p:cNvPr id="6" name="Image 0" descr="Monitoring map screenshot">    </p:cNvPr>
+          <p:cNvPr id="6" name="Image 0" descr="The map makes inspection records spatially interpretable">    </p:cNvPr>
           <p:cNvPicPr>
             <a:picLocks noChangeAspect="1"/>
           </p:cNvPicPr>
@@ -3382,7 +3040,7 @@
         <p:spPr>
           <a:xfrm>
             <a:off x="502920" y="1353312"/>
-            <a:ext cx="6629400" cy="4526280"/>
+            <a:ext cx="6903720" cy="4526280"/>
           </a:xfrm>
           <a:prstGeom prst="rect">
             <a:avLst/>
@@ -3397,8 +3055,8 @@
         </p:nvSpPr>
         <p:spPr>
           <a:xfrm>
-            <a:off x="7406640" y="1591056"/>
-            <a:ext cx="3657600" cy="2331720"/>
+            <a:off x="7726680" y="1508760"/>
+            <a:ext cx="3474720" cy="1828800"/>
           </a:xfrm>
           <a:prstGeom prst="rect">
             <a:avLst/>
@@ -3407,51 +3065,90 @@
           <a:ln/>
         </p:spPr>
         <p:txBody>
-          <a:bodyPr wrap="square" lIns="1016" tIns="1016" rIns="1016" bIns="1016" rtlCol="0" anchor="ctr">
+          <a:bodyPr wrap="square" lIns="0" tIns="0" rIns="0" bIns="0" rtlCol="0" anchor="ctr">
             <a:normAutofit/>
           </a:bodyPr>
           <a:lstStyle/>
           <a:p>
-            <a:r>
-              <a:rPr lang="en-US" sz="1450" dirty="0">
+            <a:pPr indent="0" marL="0">
+              <a:buNone/>
+            </a:pPr>
+            <a:r>
+              <a:rPr lang="en-US" sz="1800" b="1" dirty="0">
                 <a:solidFill>
                   <a:srgbClr val="102033"/>
                 </a:solidFill>
-                <a:latin typeface="Aptos" pitchFamily="34" charset="0"/>
-                <a:ea typeface="Aptos" pitchFamily="34" charset="-122"/>
-                <a:cs typeface="Aptos" pitchFamily="34" charset="-120"/>
               </a:rPr>
-              <a:t>Each record carries latitude, longitude, severity, confidence, and item count.</a:t>
-            </a:r>
-            <a:endParaRPr lang="en-US" sz="1450" dirty="0"/>
-          </a:p>
-          <a:p>
-            <a:r>
-              <a:rPr lang="en-US" sz="1450" dirty="0">
+              <a:t>The map highlights inspection sites while keeping the final log clean and presentation-ready.</a:t>
+            </a:r>
+            <a:endParaRPr lang="en-US" sz="1800" dirty="0"/>
+          </a:p>
+        </p:txBody>
+      </p:sp>
+      <p:sp>
+        <p:nvSpPr>
+          <p:cNvPr id="8" name="Shape 5"/>
+          <p:cNvSpPr/>
+          <p:nvPr/>
+        </p:nvSpPr>
+        <p:spPr>
+          <a:xfrm>
+            <a:off x="7790688" y="4526280"/>
+            <a:ext cx="3246120" cy="384048"/>
+          </a:xfrm>
+          <a:prstGeom prst="roundRect">
+            <a:avLst>
+              <a:gd name="adj" fmla="val 19048"/>
+            </a:avLst>
+          </a:prstGeom>
+          <a:solidFill>
+            <a:srgbClr val="24313F"/>
+          </a:solidFill>
+          <a:ln w="12700">
+            <a:solidFill>
+              <a:srgbClr val="24313F">
+                <a:alpha val="0"/>
+              </a:srgbClr>
+            </a:solidFill>
+            <a:prstDash val="solid"/>
+          </a:ln>
+        </p:spPr>
+      </p:sp>
+      <p:sp>
+        <p:nvSpPr>
+          <p:cNvPr id="9" name="Text 6"/>
+          <p:cNvSpPr/>
+          <p:nvPr/>
+        </p:nvSpPr>
+        <p:spPr>
+          <a:xfrm>
+            <a:off x="7882128" y="4617720"/>
+            <a:ext cx="3063240" cy="164592"/>
+          </a:xfrm>
+          <a:prstGeom prst="rect">
+            <a:avLst/>
+          </a:prstGeom>
+          <a:noFill/>
+          <a:ln/>
+        </p:spPr>
+        <p:txBody>
+          <a:bodyPr wrap="square" lIns="0" tIns="0" rIns="0" bIns="0" rtlCol="0" anchor="ctr">
+            <a:normAutofit/>
+          </a:bodyPr>
+          <a:lstStyle/>
+          <a:p>
+            <a:pPr algn="ctr" indent="0" marL="0">
+              <a:buNone/>
+            </a:pPr>
+            <a:r>
+              <a:rPr lang="en-US" sz="850" b="1" dirty="0">
                 <a:solidFill>
-                  <a:srgbClr val="102033"/>
+                  <a:srgbClr val="FFFFFF"/>
                 </a:solidFill>
-                <a:latin typeface="Aptos" pitchFamily="34" charset="0"/>
-                <a:ea typeface="Aptos" pitchFamily="34" charset="-122"/>
-                <a:cs typeface="Aptos" pitchFamily="34" charset="-120"/>
               </a:rPr>
-              <a:t>High-severity sites are easy to spot during the live demo.</a:t>
-            </a:r>
-            <a:endParaRPr lang="en-US" sz="1450" dirty="0"/>
-          </a:p>
-          <a:p>
-            <a:r>
-              <a:rPr lang="en-US" sz="1450" dirty="0">
-                <a:solidFill>
-                  <a:srgbClr val="102033"/>
-                </a:solidFill>
-                <a:latin typeface="Aptos" pitchFamily="34" charset="0"/>
-                <a:ea typeface="Aptos" pitchFamily="34" charset="-122"/>
-                <a:cs typeface="Aptos" pitchFamily="34" charset="-120"/>
-              </a:rPr>
-              <a:t>Image names are hidden from the log and map details for a cleaner final view.</a:t>
-            </a:r>
-            <a:endParaRPr lang="en-US" sz="1450" dirty="0"/>
+              <a:t>Severity and location are visible without image names</a:t>
+            </a:r>
+            <a:endParaRPr lang="en-US" sz="850" dirty="0"/>
           </a:p>
         </p:txBody>
       </p:sp>
@@ -3519,7 +3216,7 @@
         <p:spPr>
           <a:xfrm>
             <a:off x="502920" y="320040"/>
-            <a:ext cx="2926080" cy="228600"/>
+            <a:ext cx="2377440" cy="219456"/>
           </a:xfrm>
           <a:prstGeom prst="rect">
             <a:avLst/>
@@ -3528,7 +3225,7 @@
           <a:ln/>
         </p:spPr>
         <p:txBody>
-          <a:bodyPr wrap="square" rtlCol="0" anchor="ctr"/>
+          <a:bodyPr wrap="square" lIns="0" tIns="0" rIns="0" bIns="0" rtlCol="0" anchor="ctr"/>
           <a:lstStyle/>
           <a:p>
             <a:pPr indent="0" marL="0">
@@ -3539,9 +3236,6 @@
                 <a:solidFill>
                   <a:srgbClr val="586878"/>
                 </a:solidFill>
-                <a:latin typeface="Aptos" pitchFamily="34" charset="0"/>
-                <a:ea typeface="Aptos" pitchFamily="34" charset="-122"/>
-                <a:cs typeface="Aptos" pitchFamily="34" charset="-120"/>
               </a:rPr>
               <a:t>PLASTIC HUNTER</a:t>
             </a:r>
@@ -3558,7 +3252,7 @@
         <p:spPr>
           <a:xfrm>
             <a:off x="502920" y="603504"/>
-            <a:ext cx="6766560" cy="411480"/>
+            <a:ext cx="7406640" cy="457200"/>
           </a:xfrm>
           <a:prstGeom prst="rect">
             <a:avLst/>
@@ -3580,9 +3274,6 @@
                 <a:solidFill>
                   <a:srgbClr val="102033"/>
                 </a:solidFill>
-                <a:latin typeface="Aptos Display" pitchFamily="34" charset="0"/>
-                <a:ea typeface="Aptos Display" pitchFamily="34" charset="-122"/>
-                <a:cs typeface="Aptos Display" pitchFamily="34" charset="-120"/>
               </a:rPr>
               <a:t>The evidence sheet exposes the assumptions judges need</a:t>
             </a:r>
@@ -3599,7 +3290,7 @@
         <p:spPr>
           <a:xfrm>
             <a:off x="502920" y="1133856"/>
-            <a:ext cx="11064240" cy="0"/>
+            <a:ext cx="11109960" cy="0"/>
           </a:xfrm>
           <a:prstGeom prst="line">
             <a:avLst/>
@@ -3615,7 +3306,7 @@
       </p:sp>
       <p:pic>
         <p:nvPicPr>
-          <p:cNvPr id="6" name="Image 0" descr="Evidence sheet screenshot">    </p:cNvPr>
+          <p:cNvPr id="6" name="Image 0" descr="The evidence sheet exposes the assumptions judges need">    </p:cNvPr>
           <p:cNvPicPr>
             <a:picLocks noChangeAspect="1"/>
           </p:cNvPicPr>
@@ -3630,7 +3321,7 @@
         <p:spPr>
           <a:xfrm>
             <a:off x="502920" y="1353312"/>
-            <a:ext cx="6629400" cy="4526280"/>
+            <a:ext cx="6903720" cy="4526280"/>
           </a:xfrm>
           <a:prstGeom prst="rect">
             <a:avLst/>
@@ -3645,8 +3336,8 @@
         </p:nvSpPr>
         <p:spPr>
           <a:xfrm>
-            <a:off x="7406640" y="1499616"/>
-            <a:ext cx="3657600" cy="2331720"/>
+            <a:off x="7726680" y="1508760"/>
+            <a:ext cx="3474720" cy="1828800"/>
           </a:xfrm>
           <a:prstGeom prst="rect">
             <a:avLst/>
@@ -3655,51 +3346,23 @@
           <a:ln/>
         </p:spPr>
         <p:txBody>
-          <a:bodyPr wrap="square" lIns="1016" tIns="1016" rIns="1016" bIns="1016" rtlCol="0" anchor="ctr">
+          <a:bodyPr wrap="square" lIns="0" tIns="0" rIns="0" bIns="0" rtlCol="0" anchor="ctr">
             <a:normAutofit/>
           </a:bodyPr>
           <a:lstStyle/>
           <a:p>
-            <a:r>
-              <a:rPr lang="en-US" sz="1450" dirty="0">
+            <a:pPr indent="0" marL="0">
+              <a:buNone/>
+            </a:pPr>
+            <a:r>
+              <a:rPr lang="en-US" sz="1800" b="1" dirty="0">
                 <a:solidFill>
                   <a:srgbClr val="102033"/>
                 </a:solidFill>
-                <a:latin typeface="Aptos" pitchFamily="34" charset="0"/>
-                <a:ea typeface="Aptos" pitchFamily="34" charset="-122"/>
-                <a:cs typeface="Aptos" pitchFamily="34" charset="-120"/>
               </a:rPr>
-              <a:t>Problem, baseline, improved case, and test conditions are available in the app.</a:t>
-            </a:r>
-            <a:endParaRPr lang="en-US" sz="1450" dirty="0"/>
-          </a:p>
-          <a:p>
-            <a:r>
-              <a:rPr lang="en-US" sz="1450" dirty="0">
-                <a:solidFill>
-                  <a:srgbClr val="102033"/>
-                </a:solidFill>
-                <a:latin typeface="Aptos" pitchFamily="34" charset="0"/>
-                <a:ea typeface="Aptos" pitchFamily="34" charset="-122"/>
-                <a:cs typeface="Aptos" pitchFamily="34" charset="-120"/>
-              </a:rPr>
-              <a:t>Primary technical and sustainability KPIs are generated from reproducible code.</a:t>
-            </a:r>
-            <a:endParaRPr lang="en-US" sz="1450" dirty="0"/>
-          </a:p>
-          <a:p>
-            <a:r>
-              <a:rPr lang="en-US" sz="1450" dirty="0">
-                <a:solidFill>
-                  <a:srgbClr val="102033"/>
-                </a:solidFill>
-                <a:latin typeface="Aptos" pitchFamily="34" charset="0"/>
-                <a:ea typeface="Aptos" pitchFamily="34" charset="-122"/>
-                <a:cs typeface="Aptos" pitchFamily="34" charset="-120"/>
-              </a:rPr>
-              <a:t>Limitations are stated directly: sonar simulation requires hardware validation.</a:t>
-            </a:r>
-            <a:endParaRPr lang="en-US" sz="1450" dirty="0"/>
+              <a:t>The app reports baseline, improved case, test conditions, KPIs, assumptions, and limitations.</a:t>
+            </a:r>
+            <a:endParaRPr lang="en-US" sz="1800" dirty="0"/>
           </a:p>
         </p:txBody>
       </p:sp>
@@ -3711,7 +3374,7 @@
         </p:nvSpPr>
         <p:spPr>
           <a:xfrm>
-            <a:off x="7543800" y="4617720"/>
+            <a:off x="7790688" y="4526280"/>
             <a:ext cx="3246120" cy="384048"/>
           </a:xfrm>
           <a:prstGeom prst="roundRect">
@@ -3720,11 +3383,11 @@
             </a:avLst>
           </a:prstGeom>
           <a:solidFill>
-            <a:srgbClr val="2F7D57"/>
+            <a:srgbClr val="24313F"/>
           </a:solidFill>
           <a:ln w="12700">
             <a:solidFill>
-              <a:srgbClr val="2F7D57">
+              <a:srgbClr val="24313F">
                 <a:alpha val="0"/>
               </a:srgbClr>
             </a:solidFill>
@@ -3740,8 +3403,8 @@
         </p:nvSpPr>
         <p:spPr>
           <a:xfrm>
-            <a:off x="7653528" y="4709160"/>
-            <a:ext cx="3026664" cy="164592"/>
+            <a:off x="7882128" y="4617720"/>
+            <a:ext cx="3063240" cy="164592"/>
           </a:xfrm>
           <a:prstGeom prst="rect">
             <a:avLst/>
@@ -3750,7 +3413,9 @@
           <a:ln/>
         </p:spPr>
         <p:txBody>
-          <a:bodyPr wrap="square" lIns="0" tIns="0" rIns="0" bIns="0" rtlCol="0" anchor="ctr"/>
+          <a:bodyPr wrap="square" lIns="0" tIns="0" rIns="0" bIns="0" rtlCol="0" anchor="ctr">
+            <a:normAutofit/>
+          </a:bodyPr>
           <a:lstStyle/>
           <a:p>
             <a:pPr algn="ctr" indent="0" marL="0">
@@ -3832,7 +3497,7 @@
         <p:spPr>
           <a:xfrm>
             <a:off x="502920" y="320040"/>
-            <a:ext cx="2926080" cy="228600"/>
+            <a:ext cx="2377440" cy="219456"/>
           </a:xfrm>
           <a:prstGeom prst="rect">
             <a:avLst/>
@@ -3841,7 +3506,7 @@
           <a:ln/>
         </p:spPr>
         <p:txBody>
-          <a:bodyPr wrap="square" rtlCol="0" anchor="ctr"/>
+          <a:bodyPr wrap="square" lIns="0" tIns="0" rIns="0" bIns="0" rtlCol="0" anchor="ctr"/>
           <a:lstStyle/>
           <a:p>
             <a:pPr indent="0" marL="0">
@@ -3852,9 +3517,6 @@
                 <a:solidFill>
                   <a:srgbClr val="586878"/>
                 </a:solidFill>
-                <a:latin typeface="Aptos" pitchFamily="34" charset="0"/>
-                <a:ea typeface="Aptos" pitchFamily="34" charset="-122"/>
-                <a:cs typeface="Aptos" pitchFamily="34" charset="-120"/>
               </a:rPr>
               <a:t>PLASTIC HUNTER</a:t>
             </a:r>
@@ -3871,7 +3533,7 @@
         <p:spPr>
           <a:xfrm>
             <a:off x="502920" y="603504"/>
-            <a:ext cx="6766560" cy="411480"/>
+            <a:ext cx="7406640" cy="457200"/>
           </a:xfrm>
           <a:prstGeom prst="rect">
             <a:avLst/>
@@ -3893,11 +3555,8 @@
                 <a:solidFill>
                   <a:srgbClr val="102033"/>
                 </a:solidFill>
-                <a:latin typeface="Aptos Display" pitchFamily="34" charset="0"/>
-                <a:ea typeface="Aptos Display" pitchFamily="34" charset="-122"/>
-                <a:cs typeface="Aptos Display" pitchFamily="34" charset="-120"/>
               </a:rPr>
-              <a:t>The final package is organized for review and reproduction</a:t>
+              <a:t>The repository is organized for final review</a:t>
             </a:r>
             <a:endParaRPr lang="en-US" sz="2500" dirty="0"/>
           </a:p>
@@ -3912,7 +3571,7 @@
         <p:spPr>
           <a:xfrm>
             <a:off x="502920" y="1133856"/>
-            <a:ext cx="11064240" cy="0"/>
+            <a:ext cx="11109960" cy="0"/>
           </a:xfrm>
           <a:prstGeom prst="line">
             <a:avLst/>
@@ -3928,28 +3587,22 @@
       </p:sp>
       <p:pic>
         <p:nvPicPr>
-          <p:cNvPr id="6" name="Image 0" descr="Architecture diagram">    </p:cNvPr>
+          <p:cNvPr id="6" name="Image 0" descr="The repository is organized for final review">    </p:cNvPr>
           <p:cNvPicPr>
             <a:picLocks noChangeAspect="1"/>
           </p:cNvPicPr>
           <p:nvPr/>
         </p:nvPicPr>
         <p:blipFill>
-          <a:blip r:embed="rId1">
-            <a:extLst>
-              <a:ext uri="{96DAC541-7B7A-43D3-8B79-37D633B846F1}">
-                <asvg:svgBlip xmlns:asvg="http://schemas.microsoft.com/office/drawing/2016/SVG/main" r:embed="rId2"/>
-              </a:ext>
-            </a:extLst>
-          </a:blip>
+          <a:blip r:embed="rId1"/>
           <a:stretch>
             <a:fillRect/>
           </a:stretch>
         </p:blipFill>
         <p:spPr>
           <a:xfrm>
-            <a:off x="594360" y="1417320"/>
-            <a:ext cx="4983480" cy="3611880"/>
+            <a:off x="502920" y="1353312"/>
+            <a:ext cx="6903720" cy="4526280"/>
           </a:xfrm>
           <a:prstGeom prst="rect">
             <a:avLst/>
@@ -3964,8 +3617,8 @@
         </p:nvSpPr>
         <p:spPr>
           <a:xfrm>
-            <a:off x="6172200" y="1389888"/>
-            <a:ext cx="4754880" cy="2331720"/>
+            <a:off x="7726680" y="1508760"/>
+            <a:ext cx="3474720" cy="1828800"/>
           </a:xfrm>
           <a:prstGeom prst="rect">
             <a:avLst/>
@@ -3974,65 +3627,23 @@
           <a:ln/>
         </p:spPr>
         <p:txBody>
-          <a:bodyPr wrap="square" lIns="1016" tIns="1016" rIns="1016" bIns="1016" rtlCol="0" anchor="ctr">
+          <a:bodyPr wrap="square" lIns="0" tIns="0" rIns="0" bIns="0" rtlCol="0" anchor="ctr">
             <a:normAutofit/>
           </a:bodyPr>
           <a:lstStyle/>
           <a:p>
-            <a:r>
-              <a:rPr lang="en-US" sz="1450" dirty="0">
+            <a:pPr indent="0" marL="0">
+              <a:buNone/>
+            </a:pPr>
+            <a:r>
+              <a:rPr lang="en-US" sz="1800" b="1" dirty="0">
                 <a:solidFill>
                   <a:srgbClr val="102033"/>
                 </a:solidFill>
-                <a:latin typeface="Aptos" pitchFamily="34" charset="0"/>
-                <a:ea typeface="Aptos" pitchFamily="34" charset="-122"/>
-                <a:cs typeface="Aptos" pitchFamily="34" charset="-120"/>
               </a:rPr>
-              <a:t>Repository includes setup, execution, parameters, assumptions, and reproduction steps.</a:t>
-            </a:r>
-            <a:endParaRPr lang="en-US" sz="1450" dirty="0"/>
-          </a:p>
-          <a:p>
-            <a:r>
-              <a:rPr lang="en-US" sz="1450" dirty="0">
-                <a:solidFill>
-                  <a:srgbClr val="102033"/>
-                </a:solidFill>
-                <a:latin typeface="Aptos" pitchFamily="34" charset="0"/>
-                <a:ea typeface="Aptos" pitchFamily="34" charset="-122"/>
-                <a:cs typeface="Aptos" pitchFamily="34" charset="-120"/>
-              </a:rPr>
-              <a:t>Runtime files, datasets, training outputs, and Replit agent artifacts were removed.</a:t>
-            </a:r>
-            <a:endParaRPr lang="en-US" sz="1450" dirty="0"/>
-          </a:p>
-          <a:p>
-            <a:r>
-              <a:rPr lang="en-US" sz="1450" dirty="0">
-                <a:solidFill>
-                  <a:srgbClr val="102033"/>
-                </a:solidFill>
-                <a:latin typeface="Aptos" pitchFamily="34" charset="0"/>
-                <a:ea typeface="Aptos" pitchFamily="34" charset="-122"/>
-                <a:cs typeface="Aptos" pitchFamily="34" charset="-120"/>
-              </a:rPr>
-              <a:t>Technical brief, screenshots, and Codespaces configuration are included for judges.</a:t>
-            </a:r>
-            <a:endParaRPr lang="en-US" sz="1450" dirty="0"/>
-          </a:p>
-          <a:p>
-            <a:r>
-              <a:rPr lang="en-US" sz="1450" dirty="0">
-                <a:solidFill>
-                  <a:srgbClr val="102033"/>
-                </a:solidFill>
-                <a:latin typeface="Aptos" pitchFamily="34" charset="0"/>
-                <a:ea typeface="Aptos" pitchFamily="34" charset="-122"/>
-                <a:cs typeface="Aptos" pitchFamily="34" charset="-120"/>
-              </a:rPr>
-              <a:t>Next step: validate sonar assumptions with acoustic hardware and deploy trained CV on GPU.</a:t>
-            </a:r>
-            <a:endParaRPr lang="en-US" sz="1450" dirty="0"/>
+              <a:t>Runtime files and training outputs were removed; the repository stays reproducible and judge-accessible.</a:t>
+            </a:r>
+            <a:endParaRPr lang="en-US" sz="1800" dirty="0"/>
           </a:p>
         </p:txBody>
       </p:sp>
@@ -4044,8 +3655,8 @@
         </p:nvSpPr>
         <p:spPr>
           <a:xfrm>
-            <a:off x="6355080" y="5257800"/>
-            <a:ext cx="4434840" cy="384048"/>
+            <a:off x="7790688" y="4526280"/>
+            <a:ext cx="3246120" cy="384048"/>
           </a:xfrm>
           <a:prstGeom prst="roundRect">
             <a:avLst>
@@ -4053,11 +3664,11 @@
             </a:avLst>
           </a:prstGeom>
           <a:solidFill>
-            <a:srgbClr val="0F766E"/>
+            <a:srgbClr val="24313F"/>
           </a:solidFill>
           <a:ln w="12700">
             <a:solidFill>
-              <a:srgbClr val="0F766E">
+              <a:srgbClr val="24313F">
                 <a:alpha val="0"/>
               </a:srgbClr>
             </a:solidFill>
@@ -4073,8 +3684,8 @@
         </p:nvSpPr>
         <p:spPr>
           <a:xfrm>
-            <a:off x="6464808" y="5349240"/>
-            <a:ext cx="4215384" cy="164592"/>
+            <a:off x="7882128" y="4617720"/>
+            <a:ext cx="3063240" cy="164592"/>
           </a:xfrm>
           <a:prstGeom prst="rect">
             <a:avLst/>
@@ -4083,7 +3694,9 @@
           <a:ln/>
         </p:spPr>
         <p:txBody>
-          <a:bodyPr wrap="square" lIns="0" tIns="0" rIns="0" bIns="0" rtlCol="0" anchor="ctr"/>
+          <a:bodyPr wrap="square" lIns="0" tIns="0" rIns="0" bIns="0" rtlCol="0" anchor="ctr">
+            <a:normAutofit/>
+          </a:bodyPr>
           <a:lstStyle/>
           <a:p>
             <a:pPr algn="ctr" indent="0" marL="0">
@@ -4095,7 +3708,7 @@
                   <a:srgbClr val="FFFFFF"/>
                 </a:solidFill>
               </a:rPr>
-              <a:t>Final repository: github.com/Wie8Ieee/plastic-hunter-final</a:t>
+              <a:t>README, technical brief, slides, screenshots, and Codespaces</a:t>
             </a:r>
             <a:endParaRPr lang="en-US" sz="850" dirty="0"/>
           </a:p>

</xml_diff>